<commit_message>
Regenerate committed examples; executive summary was empty
The committed report artifacts predated the executive-summary population
in build_report_data, so every showcase report (HTML/DOCX/PDF/PPTX)
showed a blank <p></p> where the summary belongs -- making the product
look broken to anyone opening a sample. Regenerated from the current
deterministic pipeline (--no-ai) so the summary is grounded and the
artifacts reproduce without an API key; the non-summary sections are
unchanged since AI only touches the executive summary.

Co-Authored-By: Claude <noreply@anthropic.com>
</commit_message>
<xml_diff>
--- a/examples/grant_report.pptx
+++ b/examples/grant_report.pptx
@@ -3457,7 +3457,7 @@
                   <a:srgbClr val="1A1A1A"/>
                 </a:solidFill>
               </a:rPr>
-              <a:t>AI-assisted narrative grounded in deterministic calculations.</a:t>
+              <a:t>Deterministic narrative (non-AI mode).</a:t>
             </a:r>
           </a:p>
           <a:p>
@@ -4038,7 +4038,7 @@
                   <a:srgbClr val="1A1A1A"/>
                 </a:solidFill>
               </a:rPr>
-              <a:t/>
+              <a:t>During the reporting period (July 2024–June 2025), Stable Homes Grant programs enrolled 260 clients across 260 households (472 individuals). Of 145 exits, 93 (64.1%) were successful and 93 (64.1%) went to permanent housing. Median household income change at exit was $0, with 46.8% of households increasing income. 5 of 5 performance measures met their targets. Headline: 64.1% of the 145 exits this period were successful, against 5 tracked measures (5 met, 0 missed).</a:t>
             </a:r>
           </a:p>
         </p:txBody>

</xml_diff>